<commit_message>
Add MapleStory M-relative rank/user-rank gap tiles; fix invalid chart XML
Adds two new dashboard tiles (T-04, T-05) comparing MapleStory M against
each competitor's weekly revenue-rank and user-rank as a signed gap with
a zero baseline, plus summary stats (% of weeks ahead/behind, average
gap). Renumbers subsequent tiles (T-06..T-09) and updates the appendix
spec accordingly.

Also fixes a latent bug in every chart with missing data points (Black
Desert Mobile's tracking gaps): pptxgenjs was emitting empty <c:v></c:v>
elements for null values, which is invalid for a numeric cache and made
some charts unparseable by other OOXML consumers. Post-processed both
decks to strip these into proper sparse gaps.

Co-Authored-By: Claude Sonnet 5 <noreply@anthropic.com>
Claude-Session: https://claude.ai/code/session_01KLgeNtKXrj11AxxgcqzV4e
</commit_message>
<xml_diff>
--- a/output/메이플스토리M_리브랜딩_전략보고서.pptx
+++ b/output/메이플스토리M_리브랜딩_전략보고서.pptx
@@ -740,119 +740,41 @@
                   <c:pt idx="0">
                     <c:v>11/17</c:v>
                   </c:pt>
-                  <c:pt idx="1">
-                    <c:v/>
-                  </c:pt>
-                  <c:pt idx="2">
-                    <c:v/>
-                  </c:pt>
                   <c:pt idx="3">
                     <c:v>12/8</c:v>
-                  </c:pt>
-                  <c:pt idx="4">
-                    <c:v/>
-                  </c:pt>
-                  <c:pt idx="5">
-                    <c:v/>
                   </c:pt>
                   <c:pt idx="6">
                     <c:v>12/29</c:v>
                   </c:pt>
-                  <c:pt idx="7">
-                    <c:v/>
-                  </c:pt>
-                  <c:pt idx="8">
-                    <c:v/>
-                  </c:pt>
                   <c:pt idx="9">
                     <c:v>1/19</c:v>
-                  </c:pt>
-                  <c:pt idx="10">
-                    <c:v/>
-                  </c:pt>
-                  <c:pt idx="11">
-                    <c:v/>
                   </c:pt>
                   <c:pt idx="12">
                     <c:v>2/9</c:v>
                   </c:pt>
-                  <c:pt idx="13">
-                    <c:v/>
-                  </c:pt>
-                  <c:pt idx="14">
-                    <c:v/>
-                  </c:pt>
                   <c:pt idx="15">
                     <c:v>3/2</c:v>
-                  </c:pt>
-                  <c:pt idx="16">
-                    <c:v/>
-                  </c:pt>
-                  <c:pt idx="17">
-                    <c:v/>
                   </c:pt>
                   <c:pt idx="18">
                     <c:v>3/23</c:v>
                   </c:pt>
-                  <c:pt idx="19">
-                    <c:v/>
-                  </c:pt>
-                  <c:pt idx="20">
-                    <c:v/>
-                  </c:pt>
                   <c:pt idx="21">
                     <c:v>4/13</c:v>
-                  </c:pt>
-                  <c:pt idx="22">
-                    <c:v/>
-                  </c:pt>
-                  <c:pt idx="23">
-                    <c:v/>
                   </c:pt>
                   <c:pt idx="24">
                     <c:v>5/4</c:v>
                   </c:pt>
-                  <c:pt idx="25">
-                    <c:v/>
-                  </c:pt>
-                  <c:pt idx="26">
-                    <c:v/>
-                  </c:pt>
                   <c:pt idx="27">
                     <c:v>5/25</c:v>
-                  </c:pt>
-                  <c:pt idx="28">
-                    <c:v/>
-                  </c:pt>
-                  <c:pt idx="29">
-                    <c:v/>
                   </c:pt>
                   <c:pt idx="30">
                     <c:v>6/15</c:v>
                   </c:pt>
-                  <c:pt idx="31">
-                    <c:v/>
-                  </c:pt>
-                  <c:pt idx="32">
-                    <c:v/>
-                  </c:pt>
                   <c:pt idx="33">
                     <c:v>7/6</c:v>
                   </c:pt>
-                  <c:pt idx="34">
-                    <c:v/>
-                  </c:pt>
-                  <c:pt idx="35">
-                    <c:v/>
-                  </c:pt>
                   <c:pt idx="36">
                     <c:v>7/27</c:v>
-                  </c:pt>
-                  <c:pt idx="37">
-                    <c:v/>
-                  </c:pt>
-                  <c:pt idx="38">
-                    <c:v/>
                   </c:pt>
                 </c:lvl>
               </c:multiLvlStrCache>
@@ -1064,119 +986,41 @@
                   <c:pt idx="0">
                     <c:v>11/17</c:v>
                   </c:pt>
-                  <c:pt idx="1">
-                    <c:v/>
-                  </c:pt>
-                  <c:pt idx="2">
-                    <c:v/>
-                  </c:pt>
                   <c:pt idx="3">
                     <c:v>12/8</c:v>
-                  </c:pt>
-                  <c:pt idx="4">
-                    <c:v/>
-                  </c:pt>
-                  <c:pt idx="5">
-                    <c:v/>
                   </c:pt>
                   <c:pt idx="6">
                     <c:v>12/29</c:v>
                   </c:pt>
-                  <c:pt idx="7">
-                    <c:v/>
-                  </c:pt>
-                  <c:pt idx="8">
-                    <c:v/>
-                  </c:pt>
                   <c:pt idx="9">
                     <c:v>1/19</c:v>
-                  </c:pt>
-                  <c:pt idx="10">
-                    <c:v/>
-                  </c:pt>
-                  <c:pt idx="11">
-                    <c:v/>
                   </c:pt>
                   <c:pt idx="12">
                     <c:v>2/9</c:v>
                   </c:pt>
-                  <c:pt idx="13">
-                    <c:v/>
-                  </c:pt>
-                  <c:pt idx="14">
-                    <c:v/>
-                  </c:pt>
                   <c:pt idx="15">
                     <c:v>3/2</c:v>
-                  </c:pt>
-                  <c:pt idx="16">
-                    <c:v/>
-                  </c:pt>
-                  <c:pt idx="17">
-                    <c:v/>
                   </c:pt>
                   <c:pt idx="18">
                     <c:v>3/23</c:v>
                   </c:pt>
-                  <c:pt idx="19">
-                    <c:v/>
-                  </c:pt>
-                  <c:pt idx="20">
-                    <c:v/>
-                  </c:pt>
                   <c:pt idx="21">
                     <c:v>4/13</c:v>
-                  </c:pt>
-                  <c:pt idx="22">
-                    <c:v/>
-                  </c:pt>
-                  <c:pt idx="23">
-                    <c:v/>
                   </c:pt>
                   <c:pt idx="24">
                     <c:v>5/4</c:v>
                   </c:pt>
-                  <c:pt idx="25">
-                    <c:v/>
-                  </c:pt>
-                  <c:pt idx="26">
-                    <c:v/>
-                  </c:pt>
                   <c:pt idx="27">
                     <c:v>5/25</c:v>
-                  </c:pt>
-                  <c:pt idx="28">
-                    <c:v/>
-                  </c:pt>
-                  <c:pt idx="29">
-                    <c:v/>
                   </c:pt>
                   <c:pt idx="30">
                     <c:v>6/15</c:v>
                   </c:pt>
-                  <c:pt idx="31">
-                    <c:v/>
-                  </c:pt>
-                  <c:pt idx="32">
-                    <c:v/>
-                  </c:pt>
                   <c:pt idx="33">
                     <c:v>7/6</c:v>
                   </c:pt>
-                  <c:pt idx="34">
-                    <c:v/>
-                  </c:pt>
-                  <c:pt idx="35">
-                    <c:v/>
-                  </c:pt>
                   <c:pt idx="36">
                     <c:v>7/27</c:v>
-                  </c:pt>
-                  <c:pt idx="37">
-                    <c:v/>
-                  </c:pt>
-                  <c:pt idx="38">
-                    <c:v/>
                   </c:pt>
                 </c:lvl>
               </c:multiLvlStrCache>
@@ -1388,119 +1232,41 @@
                   <c:pt idx="0">
                     <c:v>11/17</c:v>
                   </c:pt>
-                  <c:pt idx="1">
-                    <c:v/>
-                  </c:pt>
-                  <c:pt idx="2">
-                    <c:v/>
-                  </c:pt>
                   <c:pt idx="3">
                     <c:v>12/8</c:v>
-                  </c:pt>
-                  <c:pt idx="4">
-                    <c:v/>
-                  </c:pt>
-                  <c:pt idx="5">
-                    <c:v/>
                   </c:pt>
                   <c:pt idx="6">
                     <c:v>12/29</c:v>
                   </c:pt>
-                  <c:pt idx="7">
-                    <c:v/>
-                  </c:pt>
-                  <c:pt idx="8">
-                    <c:v/>
-                  </c:pt>
                   <c:pt idx="9">
                     <c:v>1/19</c:v>
-                  </c:pt>
-                  <c:pt idx="10">
-                    <c:v/>
-                  </c:pt>
-                  <c:pt idx="11">
-                    <c:v/>
                   </c:pt>
                   <c:pt idx="12">
                     <c:v>2/9</c:v>
                   </c:pt>
-                  <c:pt idx="13">
-                    <c:v/>
-                  </c:pt>
-                  <c:pt idx="14">
-                    <c:v/>
-                  </c:pt>
                   <c:pt idx="15">
                     <c:v>3/2</c:v>
-                  </c:pt>
-                  <c:pt idx="16">
-                    <c:v/>
-                  </c:pt>
-                  <c:pt idx="17">
-                    <c:v/>
                   </c:pt>
                   <c:pt idx="18">
                     <c:v>3/23</c:v>
                   </c:pt>
-                  <c:pt idx="19">
-                    <c:v/>
-                  </c:pt>
-                  <c:pt idx="20">
-                    <c:v/>
-                  </c:pt>
                   <c:pt idx="21">
                     <c:v>4/13</c:v>
-                  </c:pt>
-                  <c:pt idx="22">
-                    <c:v/>
-                  </c:pt>
-                  <c:pt idx="23">
-                    <c:v/>
                   </c:pt>
                   <c:pt idx="24">
                     <c:v>5/4</c:v>
                   </c:pt>
-                  <c:pt idx="25">
-                    <c:v/>
-                  </c:pt>
-                  <c:pt idx="26">
-                    <c:v/>
-                  </c:pt>
                   <c:pt idx="27">
                     <c:v>5/25</c:v>
-                  </c:pt>
-                  <c:pt idx="28">
-                    <c:v/>
-                  </c:pt>
-                  <c:pt idx="29">
-                    <c:v/>
                   </c:pt>
                   <c:pt idx="30">
                     <c:v>6/15</c:v>
                   </c:pt>
-                  <c:pt idx="31">
-                    <c:v/>
-                  </c:pt>
-                  <c:pt idx="32">
-                    <c:v/>
-                  </c:pt>
                   <c:pt idx="33">
                     <c:v>7/6</c:v>
                   </c:pt>
-                  <c:pt idx="34">
-                    <c:v/>
-                  </c:pt>
-                  <c:pt idx="35">
-                    <c:v/>
-                  </c:pt>
                   <c:pt idx="36">
                     <c:v>7/27</c:v>
-                  </c:pt>
-                  <c:pt idx="37">
-                    <c:v/>
-                  </c:pt>
-                  <c:pt idx="38">
-                    <c:v/>
                   </c:pt>
                 </c:lvl>
               </c:multiLvlStrCache>
@@ -1712,119 +1478,41 @@
                   <c:pt idx="0">
                     <c:v>11/17</c:v>
                   </c:pt>
-                  <c:pt idx="1">
-                    <c:v/>
-                  </c:pt>
-                  <c:pt idx="2">
-                    <c:v/>
-                  </c:pt>
                   <c:pt idx="3">
                     <c:v>12/8</c:v>
-                  </c:pt>
-                  <c:pt idx="4">
-                    <c:v/>
-                  </c:pt>
-                  <c:pt idx="5">
-                    <c:v/>
                   </c:pt>
                   <c:pt idx="6">
                     <c:v>12/29</c:v>
                   </c:pt>
-                  <c:pt idx="7">
-                    <c:v/>
-                  </c:pt>
-                  <c:pt idx="8">
-                    <c:v/>
-                  </c:pt>
                   <c:pt idx="9">
                     <c:v>1/19</c:v>
-                  </c:pt>
-                  <c:pt idx="10">
-                    <c:v/>
-                  </c:pt>
-                  <c:pt idx="11">
-                    <c:v/>
                   </c:pt>
                   <c:pt idx="12">
                     <c:v>2/9</c:v>
                   </c:pt>
-                  <c:pt idx="13">
-                    <c:v/>
-                  </c:pt>
-                  <c:pt idx="14">
-                    <c:v/>
-                  </c:pt>
                   <c:pt idx="15">
                     <c:v>3/2</c:v>
-                  </c:pt>
-                  <c:pt idx="16">
-                    <c:v/>
-                  </c:pt>
-                  <c:pt idx="17">
-                    <c:v/>
                   </c:pt>
                   <c:pt idx="18">
                     <c:v>3/23</c:v>
                   </c:pt>
-                  <c:pt idx="19">
-                    <c:v/>
-                  </c:pt>
-                  <c:pt idx="20">
-                    <c:v/>
-                  </c:pt>
                   <c:pt idx="21">
                     <c:v>4/13</c:v>
-                  </c:pt>
-                  <c:pt idx="22">
-                    <c:v/>
-                  </c:pt>
-                  <c:pt idx="23">
-                    <c:v/>
                   </c:pt>
                   <c:pt idx="24">
                     <c:v>5/4</c:v>
                   </c:pt>
-                  <c:pt idx="25">
-                    <c:v/>
-                  </c:pt>
-                  <c:pt idx="26">
-                    <c:v/>
-                  </c:pt>
                   <c:pt idx="27">
                     <c:v>5/25</c:v>
-                  </c:pt>
-                  <c:pt idx="28">
-                    <c:v/>
-                  </c:pt>
-                  <c:pt idx="29">
-                    <c:v/>
                   </c:pt>
                   <c:pt idx="30">
                     <c:v>6/15</c:v>
                   </c:pt>
-                  <c:pt idx="31">
-                    <c:v/>
-                  </c:pt>
-                  <c:pt idx="32">
-                    <c:v/>
-                  </c:pt>
                   <c:pt idx="33">
                     <c:v>7/6</c:v>
                   </c:pt>
-                  <c:pt idx="34">
-                    <c:v/>
-                  </c:pt>
-                  <c:pt idx="35">
-                    <c:v/>
-                  </c:pt>
                   <c:pt idx="36">
                     <c:v>7/27</c:v>
-                  </c:pt>
-                  <c:pt idx="37">
-                    <c:v/>
-                  </c:pt>
-                  <c:pt idx="38">
-                    <c:v/>
                   </c:pt>
                 </c:lvl>
               </c:multiLvlStrCache>
@@ -1940,18 +1628,6 @@
                 </c:pt>
                 <c:pt idx="34">
                   <c:v>159</c:v>
-                </c:pt>
-                <c:pt idx="35">
-                  <c:v/>
-                </c:pt>
-                <c:pt idx="36">
-                  <c:v/>
-                </c:pt>
-                <c:pt idx="37">
-                  <c:v/>
-                </c:pt>
-                <c:pt idx="38">
-                  <c:v/>
                 </c:pt>
               </c:numCache>
             </c:numRef>
@@ -2234,119 +1910,41 @@
                   <c:pt idx="0">
                     <c:v>11/17</c:v>
                   </c:pt>
-                  <c:pt idx="1">
-                    <c:v/>
-                  </c:pt>
-                  <c:pt idx="2">
-                    <c:v/>
-                  </c:pt>
                   <c:pt idx="3">
                     <c:v>12/8</c:v>
-                  </c:pt>
-                  <c:pt idx="4">
-                    <c:v/>
-                  </c:pt>
-                  <c:pt idx="5">
-                    <c:v/>
                   </c:pt>
                   <c:pt idx="6">
                     <c:v>12/29</c:v>
                   </c:pt>
-                  <c:pt idx="7">
-                    <c:v/>
-                  </c:pt>
-                  <c:pt idx="8">
-                    <c:v/>
-                  </c:pt>
                   <c:pt idx="9">
                     <c:v>1/19</c:v>
-                  </c:pt>
-                  <c:pt idx="10">
-                    <c:v/>
-                  </c:pt>
-                  <c:pt idx="11">
-                    <c:v/>
                   </c:pt>
                   <c:pt idx="12">
                     <c:v>2/9</c:v>
                   </c:pt>
-                  <c:pt idx="13">
-                    <c:v/>
-                  </c:pt>
-                  <c:pt idx="14">
-                    <c:v/>
-                  </c:pt>
                   <c:pt idx="15">
                     <c:v>3/2</c:v>
-                  </c:pt>
-                  <c:pt idx="16">
-                    <c:v/>
-                  </c:pt>
-                  <c:pt idx="17">
-                    <c:v/>
                   </c:pt>
                   <c:pt idx="18">
                     <c:v>3/23</c:v>
                   </c:pt>
-                  <c:pt idx="19">
-                    <c:v/>
-                  </c:pt>
-                  <c:pt idx="20">
-                    <c:v/>
-                  </c:pt>
                   <c:pt idx="21">
                     <c:v>4/13</c:v>
-                  </c:pt>
-                  <c:pt idx="22">
-                    <c:v/>
-                  </c:pt>
-                  <c:pt idx="23">
-                    <c:v/>
                   </c:pt>
                   <c:pt idx="24">
                     <c:v>5/4</c:v>
                   </c:pt>
-                  <c:pt idx="25">
-                    <c:v/>
-                  </c:pt>
-                  <c:pt idx="26">
-                    <c:v/>
-                  </c:pt>
                   <c:pt idx="27">
                     <c:v>5/25</c:v>
-                  </c:pt>
-                  <c:pt idx="28">
-                    <c:v/>
-                  </c:pt>
-                  <c:pt idx="29">
-                    <c:v/>
                   </c:pt>
                   <c:pt idx="30">
                     <c:v>6/15</c:v>
                   </c:pt>
-                  <c:pt idx="31">
-                    <c:v/>
-                  </c:pt>
-                  <c:pt idx="32">
-                    <c:v/>
-                  </c:pt>
                   <c:pt idx="33">
                     <c:v>7/6</c:v>
                   </c:pt>
-                  <c:pt idx="34">
-                    <c:v/>
-                  </c:pt>
-                  <c:pt idx="35">
-                    <c:v/>
-                  </c:pt>
                   <c:pt idx="36">
                     <c:v>7/27</c:v>
-                  </c:pt>
-                  <c:pt idx="37">
-                    <c:v/>
-                  </c:pt>
-                  <c:pt idx="38">
-                    <c:v/>
                   </c:pt>
                 </c:lvl>
               </c:multiLvlStrCache>
@@ -2558,119 +2156,41 @@
                   <c:pt idx="0">
                     <c:v>11/17</c:v>
                   </c:pt>
-                  <c:pt idx="1">
-                    <c:v/>
-                  </c:pt>
-                  <c:pt idx="2">
-                    <c:v/>
-                  </c:pt>
                   <c:pt idx="3">
                     <c:v>12/8</c:v>
-                  </c:pt>
-                  <c:pt idx="4">
-                    <c:v/>
-                  </c:pt>
-                  <c:pt idx="5">
-                    <c:v/>
                   </c:pt>
                   <c:pt idx="6">
                     <c:v>12/29</c:v>
                   </c:pt>
-                  <c:pt idx="7">
-                    <c:v/>
-                  </c:pt>
-                  <c:pt idx="8">
-                    <c:v/>
-                  </c:pt>
                   <c:pt idx="9">
                     <c:v>1/19</c:v>
-                  </c:pt>
-                  <c:pt idx="10">
-                    <c:v/>
-                  </c:pt>
-                  <c:pt idx="11">
-                    <c:v/>
                   </c:pt>
                   <c:pt idx="12">
                     <c:v>2/9</c:v>
                   </c:pt>
-                  <c:pt idx="13">
-                    <c:v/>
-                  </c:pt>
-                  <c:pt idx="14">
-                    <c:v/>
-                  </c:pt>
                   <c:pt idx="15">
                     <c:v>3/2</c:v>
-                  </c:pt>
-                  <c:pt idx="16">
-                    <c:v/>
-                  </c:pt>
-                  <c:pt idx="17">
-                    <c:v/>
                   </c:pt>
                   <c:pt idx="18">
                     <c:v>3/23</c:v>
                   </c:pt>
-                  <c:pt idx="19">
-                    <c:v/>
-                  </c:pt>
-                  <c:pt idx="20">
-                    <c:v/>
-                  </c:pt>
                   <c:pt idx="21">
                     <c:v>4/13</c:v>
-                  </c:pt>
-                  <c:pt idx="22">
-                    <c:v/>
-                  </c:pt>
-                  <c:pt idx="23">
-                    <c:v/>
                   </c:pt>
                   <c:pt idx="24">
                     <c:v>5/4</c:v>
                   </c:pt>
-                  <c:pt idx="25">
-                    <c:v/>
-                  </c:pt>
-                  <c:pt idx="26">
-                    <c:v/>
-                  </c:pt>
                   <c:pt idx="27">
                     <c:v>5/25</c:v>
-                  </c:pt>
-                  <c:pt idx="28">
-                    <c:v/>
-                  </c:pt>
-                  <c:pt idx="29">
-                    <c:v/>
                   </c:pt>
                   <c:pt idx="30">
                     <c:v>6/15</c:v>
                   </c:pt>
-                  <c:pt idx="31">
-                    <c:v/>
-                  </c:pt>
-                  <c:pt idx="32">
-                    <c:v/>
-                  </c:pt>
                   <c:pt idx="33">
                     <c:v>7/6</c:v>
                   </c:pt>
-                  <c:pt idx="34">
-                    <c:v/>
-                  </c:pt>
-                  <c:pt idx="35">
-                    <c:v/>
-                  </c:pt>
                   <c:pt idx="36">
                     <c:v>7/27</c:v>
-                  </c:pt>
-                  <c:pt idx="37">
-                    <c:v/>
-                  </c:pt>
-                  <c:pt idx="38">
-                    <c:v/>
                   </c:pt>
                 </c:lvl>
               </c:multiLvlStrCache>
@@ -2882,119 +2402,41 @@
                   <c:pt idx="0">
                     <c:v>11/17</c:v>
                   </c:pt>
-                  <c:pt idx="1">
-                    <c:v/>
-                  </c:pt>
-                  <c:pt idx="2">
-                    <c:v/>
-                  </c:pt>
                   <c:pt idx="3">
                     <c:v>12/8</c:v>
-                  </c:pt>
-                  <c:pt idx="4">
-                    <c:v/>
-                  </c:pt>
-                  <c:pt idx="5">
-                    <c:v/>
                   </c:pt>
                   <c:pt idx="6">
                     <c:v>12/29</c:v>
                   </c:pt>
-                  <c:pt idx="7">
-                    <c:v/>
-                  </c:pt>
-                  <c:pt idx="8">
-                    <c:v/>
-                  </c:pt>
                   <c:pt idx="9">
                     <c:v>1/19</c:v>
-                  </c:pt>
-                  <c:pt idx="10">
-                    <c:v/>
-                  </c:pt>
-                  <c:pt idx="11">
-                    <c:v/>
                   </c:pt>
                   <c:pt idx="12">
                     <c:v>2/9</c:v>
                   </c:pt>
-                  <c:pt idx="13">
-                    <c:v/>
-                  </c:pt>
-                  <c:pt idx="14">
-                    <c:v/>
-                  </c:pt>
                   <c:pt idx="15">
                     <c:v>3/2</c:v>
-                  </c:pt>
-                  <c:pt idx="16">
-                    <c:v/>
-                  </c:pt>
-                  <c:pt idx="17">
-                    <c:v/>
                   </c:pt>
                   <c:pt idx="18">
                     <c:v>3/23</c:v>
                   </c:pt>
-                  <c:pt idx="19">
-                    <c:v/>
-                  </c:pt>
-                  <c:pt idx="20">
-                    <c:v/>
-                  </c:pt>
                   <c:pt idx="21">
                     <c:v>4/13</c:v>
-                  </c:pt>
-                  <c:pt idx="22">
-                    <c:v/>
-                  </c:pt>
-                  <c:pt idx="23">
-                    <c:v/>
                   </c:pt>
                   <c:pt idx="24">
                     <c:v>5/4</c:v>
                   </c:pt>
-                  <c:pt idx="25">
-                    <c:v/>
-                  </c:pt>
-                  <c:pt idx="26">
-                    <c:v/>
-                  </c:pt>
                   <c:pt idx="27">
                     <c:v>5/25</c:v>
-                  </c:pt>
-                  <c:pt idx="28">
-                    <c:v/>
-                  </c:pt>
-                  <c:pt idx="29">
-                    <c:v/>
                   </c:pt>
                   <c:pt idx="30">
                     <c:v>6/15</c:v>
                   </c:pt>
-                  <c:pt idx="31">
-                    <c:v/>
-                  </c:pt>
-                  <c:pt idx="32">
-                    <c:v/>
-                  </c:pt>
                   <c:pt idx="33">
                     <c:v>7/6</c:v>
                   </c:pt>
-                  <c:pt idx="34">
-                    <c:v/>
-                  </c:pt>
-                  <c:pt idx="35">
-                    <c:v/>
-                  </c:pt>
                   <c:pt idx="36">
                     <c:v>7/27</c:v>
-                  </c:pt>
-                  <c:pt idx="37">
-                    <c:v/>
-                  </c:pt>
-                  <c:pt idx="38">
-                    <c:v/>
                   </c:pt>
                 </c:lvl>
               </c:multiLvlStrCache>
@@ -3206,119 +2648,41 @@
                   <c:pt idx="0">
                     <c:v>11/17</c:v>
                   </c:pt>
-                  <c:pt idx="1">
-                    <c:v/>
-                  </c:pt>
-                  <c:pt idx="2">
-                    <c:v/>
-                  </c:pt>
                   <c:pt idx="3">
                     <c:v>12/8</c:v>
-                  </c:pt>
-                  <c:pt idx="4">
-                    <c:v/>
-                  </c:pt>
-                  <c:pt idx="5">
-                    <c:v/>
                   </c:pt>
                   <c:pt idx="6">
                     <c:v>12/29</c:v>
                   </c:pt>
-                  <c:pt idx="7">
-                    <c:v/>
-                  </c:pt>
-                  <c:pt idx="8">
-                    <c:v/>
-                  </c:pt>
                   <c:pt idx="9">
                     <c:v>1/19</c:v>
-                  </c:pt>
-                  <c:pt idx="10">
-                    <c:v/>
-                  </c:pt>
-                  <c:pt idx="11">
-                    <c:v/>
                   </c:pt>
                   <c:pt idx="12">
                     <c:v>2/9</c:v>
                   </c:pt>
-                  <c:pt idx="13">
-                    <c:v/>
-                  </c:pt>
-                  <c:pt idx="14">
-                    <c:v/>
-                  </c:pt>
                   <c:pt idx="15">
                     <c:v>3/2</c:v>
-                  </c:pt>
-                  <c:pt idx="16">
-                    <c:v/>
-                  </c:pt>
-                  <c:pt idx="17">
-                    <c:v/>
                   </c:pt>
                   <c:pt idx="18">
                     <c:v>3/23</c:v>
                   </c:pt>
-                  <c:pt idx="19">
-                    <c:v/>
-                  </c:pt>
-                  <c:pt idx="20">
-                    <c:v/>
-                  </c:pt>
                   <c:pt idx="21">
                     <c:v>4/13</c:v>
-                  </c:pt>
-                  <c:pt idx="22">
-                    <c:v/>
-                  </c:pt>
-                  <c:pt idx="23">
-                    <c:v/>
                   </c:pt>
                   <c:pt idx="24">
                     <c:v>5/4</c:v>
                   </c:pt>
-                  <c:pt idx="25">
-                    <c:v/>
-                  </c:pt>
-                  <c:pt idx="26">
-                    <c:v/>
-                  </c:pt>
                   <c:pt idx="27">
                     <c:v>5/25</c:v>
-                  </c:pt>
-                  <c:pt idx="28">
-                    <c:v/>
-                  </c:pt>
-                  <c:pt idx="29">
-                    <c:v/>
                   </c:pt>
                   <c:pt idx="30">
                     <c:v>6/15</c:v>
                   </c:pt>
-                  <c:pt idx="31">
-                    <c:v/>
-                  </c:pt>
-                  <c:pt idx="32">
-                    <c:v/>
-                  </c:pt>
                   <c:pt idx="33">
                     <c:v>7/6</c:v>
                   </c:pt>
-                  <c:pt idx="34">
-                    <c:v/>
-                  </c:pt>
-                  <c:pt idx="35">
-                    <c:v/>
-                  </c:pt>
                   <c:pt idx="36">
                     <c:v>7/27</c:v>
-                  </c:pt>
-                  <c:pt idx="37">
-                    <c:v/>
-                  </c:pt>
-                  <c:pt idx="38">
-                    <c:v/>
                   </c:pt>
                 </c:lvl>
               </c:multiLvlStrCache>
@@ -3330,15 +2694,6 @@
               <c:numCache>
                 <c:formatCode>General</c:formatCode>
                 <c:ptCount val="39"/>
-                <c:pt idx="0">
-                  <c:v/>
-                </c:pt>
-                <c:pt idx="1">
-                  <c:v/>
-                </c:pt>
-                <c:pt idx="2">
-                  <c:v/>
-                </c:pt>
                 <c:pt idx="3">
                   <c:v>269</c:v>
                 </c:pt>
@@ -3348,104 +2703,11 @@
                 <c:pt idx="5">
                   <c:v>199</c:v>
                 </c:pt>
-                <c:pt idx="6">
-                  <c:v/>
-                </c:pt>
-                <c:pt idx="7">
-                  <c:v/>
-                </c:pt>
-                <c:pt idx="8">
-                  <c:v/>
-                </c:pt>
-                <c:pt idx="9">
-                  <c:v/>
-                </c:pt>
-                <c:pt idx="10">
-                  <c:v/>
-                </c:pt>
-                <c:pt idx="11">
-                  <c:v/>
-                </c:pt>
-                <c:pt idx="12">
-                  <c:v/>
-                </c:pt>
-                <c:pt idx="13">
-                  <c:v/>
-                </c:pt>
-                <c:pt idx="14">
-                  <c:v/>
-                </c:pt>
                 <c:pt idx="15">
                   <c:v>159</c:v>
                 </c:pt>
                 <c:pt idx="16">
                   <c:v>165</c:v>
-                </c:pt>
-                <c:pt idx="17">
-                  <c:v/>
-                </c:pt>
-                <c:pt idx="18">
-                  <c:v/>
-                </c:pt>
-                <c:pt idx="19">
-                  <c:v/>
-                </c:pt>
-                <c:pt idx="20">
-                  <c:v/>
-                </c:pt>
-                <c:pt idx="21">
-                  <c:v/>
-                </c:pt>
-                <c:pt idx="22">
-                  <c:v/>
-                </c:pt>
-                <c:pt idx="23">
-                  <c:v/>
-                </c:pt>
-                <c:pt idx="24">
-                  <c:v/>
-                </c:pt>
-                <c:pt idx="25">
-                  <c:v/>
-                </c:pt>
-                <c:pt idx="26">
-                  <c:v/>
-                </c:pt>
-                <c:pt idx="27">
-                  <c:v/>
-                </c:pt>
-                <c:pt idx="28">
-                  <c:v/>
-                </c:pt>
-                <c:pt idx="29">
-                  <c:v/>
-                </c:pt>
-                <c:pt idx="30">
-                  <c:v/>
-                </c:pt>
-                <c:pt idx="31">
-                  <c:v/>
-                </c:pt>
-                <c:pt idx="32">
-                  <c:v/>
-                </c:pt>
-                <c:pt idx="33">
-                  <c:v/>
-                </c:pt>
-                <c:pt idx="34">
-                  <c:v/>
-                </c:pt>
-                <c:pt idx="35">
-                  <c:v/>
-                </c:pt>
-                <c:pt idx="36">
-                  <c:v/>
-                </c:pt>
-                <c:pt idx="37">
-                  <c:v/>
-                </c:pt>
-                <c:pt idx="38">
-                  <c:v/>
                 </c:pt>
               </c:numCache>
             </c:numRef>

</xml_diff>